<commit_message>
Deck/README: confident positive titles instead of defensive phrasing
Co-Authored-By: Claude Opus 5.5 <noreply@anthropic.com>
</commit_message>
<xml_diff>
--- a/presentation/deck.pptx
+++ b/presentation/deck.pptx
@@ -115,39 +115,39 @@
   <p:extLst>
     <p:ext uri="{521415D9-36F7-43E2-AB2F-B90AF26B5E84}">
       <p14:sectionLst xmlns:p14="http://schemas.microsoft.com/office/powerpoint/2010/main">
-        <p14:section name="Hook" id="{59ec4628-d784-ed23-fd15-626dc1c2e3bd}">
+        <p14:section name="Hook" id="{9bc89371-0c22-3afc-fe62-fecee0f72fb8}">
           <p14:sldIdLst>
             <p14:sldId id="256"/>
           </p14:sldIdLst>
         </p14:section>
-        <p14:section name="Problem" id="{c3f3769e-c70d-3066-102c-29ff0e066170}">
+        <p14:section name="Problem" id="{1c080237-4f48-c938-cafe-3cfb7b336872}">
           <p14:sldIdLst>
             <p14:sldId id="257"/>
           </p14:sldIdLst>
         </p14:section>
-        <p14:section name="Solution" id="{6ee57135-247f-3489-5885-27d4aa9896f2}">
+        <p14:section name="Solution" id="{38d83439-2c65-0ed4-628c-bc184433e50c}">
           <p14:sldIdLst>
             <p14:sldId id="258"/>
           </p14:sldIdLst>
         </p14:section>
-        <p14:section name="Results" id="{9bedd7c6-a221-8ba5-2447-fb8bf30a92f1}">
+        <p14:section name="Results" id="{4c91433b-b1f7-0167-4212-eb321d519b3e}">
           <p14:sldIdLst>
             <p14:sldId id="259"/>
             <p14:sldId id="260"/>
             <p14:sldId id="261"/>
           </p14:sldIdLst>
         </p14:section>
-        <p14:section name="Working together" id="{f0322927-5b63-f77e-4e4f-75d7bbdb5957}">
+        <p14:section name="Working together" id="{ee611d1f-ef7a-10b3-e5ab-72891e844316}">
           <p14:sldIdLst>
             <p14:sldId id="262"/>
           </p14:sldIdLst>
         </p14:section>
-        <p14:section name="Call to action" id="{7241bfa1-d895-5a7b-df85-eea38735409b}">
+        <p14:section name="Call to action" id="{7acc09b3-df5f-0943-0341-7b7b6d4928f7}">
           <p14:sldIdLst>
             <p14:sldId id="263"/>
           </p14:sldIdLst>
         </p14:section>
-        <p14:section name="Appendix" id="{63f30baa-70f5-788d-1ce4-b3eacaaf87d1}">
+        <p14:section name="Appendix" id="{3b0009d7-8ef5-ccad-b1c0-7e388f50a0bc}">
           <p14:sldIdLst>
             <p14:sldId id="264"/>
           </p14:sldIdLst>
@@ -6740,7 +6740,7 @@
                 <a:ea typeface="Arial" pitchFamily="34" charset="-122"/>
                 <a:cs typeface="Arial" pitchFamily="34" charset="-120"/>
               </a:rPr>
-              <a:t>Representative, not cherry-picked.</a:t>
+              <a:t>Defects found on parts it never saw.</a:t>
             </a:r>
             <a:endParaRPr lang="en-US" sz="3400" dirty="0"/>
           </a:p>
@@ -7932,7 +7932,7 @@
                 <a:ea typeface="Arial" pitchFamily="34" charset="-122"/>
                 <a:cs typeface="Arial" pitchFamily="34" charset="-120"/>
               </a:rPr>
-              <a:t>Benchmarked, not guessed.</a:t>
+              <a:t>The numbers behind it.</a:t>
             </a:r>
             <a:endParaRPr lang="en-US" sz="3400" dirty="0"/>
           </a:p>

</xml_diff>